<commit_message>
Deck build script and WSA page-four answers
</commit_message>
<xml_diff>
--- a/ref/decks/tanitxr-partnership-deck.pptx
+++ b/ref/decks/tanitxr-partnership-deck.pptx
@@ -4120,9 +4120,7 @@
           <p:nvPr/>
         </p:nvPicPr>
         <p:blipFill>
-          <a:blip r:embed="rId1">
-            <a:alphaModFix amt="30000"/>
-          </a:blip>
+          <a:blip r:embed="rId1"/>
           <a:srcRect l="0" r="0" t="0" b="0"/>
           <a:stretch/>
         </p:blipFill>
@@ -4138,7 +4136,36 @@
       </p:pic>
       <p:sp>
         <p:nvSpPr>
-          <p:cNvPr id="3" name="Text 0"/>
+          <p:cNvPr id="3" name="Shape 0"/>
+          <p:cNvSpPr/>
+          <p:nvPr/>
+        </p:nvSpPr>
+        <p:spPr>
+          <a:xfrm>
+            <a:off x="0" y="0"/>
+            <a:ext cx="12188952" cy="6858000"/>
+          </a:xfrm>
+          <a:prstGeom prst="rect">
+            <a:avLst/>
+          </a:prstGeom>
+          <a:solidFill>
+            <a:srgbClr val="241A10">
+              <a:alpha val="72000"/>
+            </a:srgbClr>
+          </a:solidFill>
+          <a:ln w="12700">
+            <a:solidFill>
+              <a:srgbClr val="241A10">
+                <a:alpha val="0"/>
+              </a:srgbClr>
+            </a:solidFill>
+            <a:prstDash val="solid"/>
+          </a:ln>
+        </p:spPr>
+      </p:sp>
+      <p:sp>
+        <p:nvSpPr>
+          <p:cNvPr id="4" name="Text 1"/>
           <p:cNvSpPr txBox="1"/>
           <p:nvPr/>
         </p:nvSpPr>
@@ -4177,7 +4204,7 @@
       </p:sp>
       <p:sp>
         <p:nvSpPr>
-          <p:cNvPr id="4" name="Text 1"/>
+          <p:cNvPr id="5" name="Text 2"/>
           <p:cNvSpPr txBox="1"/>
           <p:nvPr/>
         </p:nvSpPr>
@@ -4216,7 +4243,7 @@
       </p:sp>
       <p:sp>
         <p:nvSpPr>
-          <p:cNvPr id="5" name="Text 2"/>
+          <p:cNvPr id="6" name="Text 3"/>
           <p:cNvSpPr txBox="1"/>
           <p:nvPr/>
         </p:nvSpPr>
@@ -4255,7 +4282,7 @@
       </p:sp>
       <p:sp>
         <p:nvSpPr>
-          <p:cNvPr id="6" name="Text 3"/>
+          <p:cNvPr id="7" name="Text 4"/>
           <p:cNvSpPr txBox="1"/>
           <p:nvPr/>
         </p:nvSpPr>
@@ -4294,7 +4321,7 @@
       </p:sp>
       <p:sp>
         <p:nvSpPr>
-          <p:cNvPr id="7" name="Text 4"/>
+          <p:cNvPr id="8" name="Text 5"/>
           <p:cNvSpPr txBox="1"/>
           <p:nvPr/>
         </p:nvSpPr>
@@ -4333,7 +4360,7 @@
       </p:sp>
       <p:sp>
         <p:nvSpPr>
-          <p:cNvPr id="8" name="Text 5"/>
+          <p:cNvPr id="9" name="Text 6"/>
           <p:cNvSpPr txBox="1"/>
           <p:nvPr/>
         </p:nvSpPr>

</xml_diff>

<commit_message>
Partner offers reframed: volunteer hours, a gallery in the museum, experiences built together, coastal care days, workshops, talks, funding the community; scanning stays with the institutions
</commit_message>
<xml_diff>
--- a/ref/decks/tanitxr-partnership-deck.pptx
+++ b/ref/decks/tanitxr-partnership-deck.pptx
@@ -2012,7 +2012,7 @@
                 <a:ea typeface="Calibri" pitchFamily="34" charset="-122"/>
                 <a:cs typeface="Calibri" pitchFamily="34" charset="-120"/>
               </a:rPr>
-              <a:t>Tanit XR is a volunteer community on four continents that 3D-scans Tunisia's endangered heritage with phones and publishes it free, in 3D, AR and VR.</a:t>
+              <a:t>Tanit XR is a volunteer community on four continents that brings Tunisia's endangered heritage into 3D and publishes it free, in 3D, AR and VR, alongside the institutions that look after the sites.</a:t>
             </a:r>
             <a:endParaRPr lang="en-US" sz="1500" dirty="0"/>
           </a:p>
@@ -2227,7 +2227,7 @@
                 <a:ea typeface="Cambria" pitchFamily="34" charset="-122"/>
                 <a:cs typeface="Cambria" pitchFamily="34" charset="-120"/>
               </a:rPr>
-              <a:t>Scanning day</a:t>
+              <a:t>Care day</a:t>
             </a:r>
             <a:endParaRPr lang="en-US" sz="1500" dirty="0"/>
           </a:p>
@@ -2305,7 +2305,7 @@
                 <a:ea typeface="Calibri" pitchFamily="34" charset="-122"/>
                 <a:cs typeface="Calibri" pitchFamily="34" charset="-120"/>
               </a:rPr>
-              <a:t>One volunteer's season of site visits: transport, data, backups.</a:t>
+              <a:t>One day of cleaning and care at a coastal site, with local volunteers paid for their time.</a:t>
             </a:r>
             <a:endParaRPr lang="en-US" sz="1150" dirty="0"/>
           </a:p>
@@ -2344,7 +2344,7 @@
                 <a:ea typeface="Calibri" pitchFamily="34" charset="-122"/>
                 <a:cs typeface="Calibri" pitchFamily="34" charset="-120"/>
               </a:rPr>
-              <a:t>Named on the objects scanned that season</a:t>
+              <a:t>Named on the day's story and pictures</a:t>
             </a:r>
             <a:endParaRPr lang="en-US" sz="1100" dirty="0"/>
           </a:p>
@@ -2410,7 +2410,7 @@
                 <a:ea typeface="Cambria" pitchFamily="34" charset="-122"/>
                 <a:cs typeface="Cambria" pitchFamily="34" charset="-120"/>
               </a:rPr>
-              <a:t>Adopt a site</a:t>
+              <a:t>Adopt a gallery</a:t>
             </a:r>
             <a:endParaRPr lang="en-US" sz="1500" dirty="0"/>
           </a:p>
@@ -2488,7 +2488,7 @@
                 <a:ea typeface="Calibri" pitchFamily="34" charset="-122"/>
                 <a:cs typeface="Calibri" pitchFamily="34" charset="-120"/>
               </a:rPr>
-              <a:t>Every object from one site, scanned, researched, published.</a:t>
+              <a:t>One gallery of the virtual museum, built, furnished and told, with your name on it.</a:t>
             </a:r>
             <a:endParaRPr lang="en-US" sz="1150" dirty="0"/>
           </a:p>
@@ -2527,7 +2527,7 @@
                 <a:ea typeface="Calibri" pitchFamily="34" charset="-122"/>
                 <a:cs typeface="Calibri" pitchFamily="34" charset="-120"/>
               </a:rPr>
-              <a:t>Your name on the site's gallery</a:t>
+              <a:t>Your name in the browser and the headset</a:t>
             </a:r>
             <a:endParaRPr lang="en-US" sz="1100" dirty="0"/>
           </a:p>
@@ -8126,7 +8126,7 @@
                 <a:ea typeface="Cambria" pitchFamily="34" charset="-122"/>
                 <a:cs typeface="Cambria" pitchFamily="34" charset="-120"/>
               </a:rPr>
-              <a:t>Your team learns to scan</a:t>
+              <a:t>Your team's hours, on real work</a:t>
             </a:r>
             <a:endParaRPr lang="en-US" sz="1450" dirty="0"/>
           </a:p>
@@ -8165,7 +8165,7 @@
                 <a:ea typeface="Calibri" pitchFamily="34" charset="-122"/>
                 <a:cs typeface="Calibri" pitchFamily="34" charset="-120"/>
               </a:rPr>
-              <a:t>A half day or a six-week course, online or on site. Your employees publish a real piece of heritage under their names.</a:t>
+              <a:t>Optimise a scan, research an object, translate a label, build a piece of the museum. Published under their names.</a:t>
             </a:r>
             <a:endParaRPr lang="en-US" sz="1150" dirty="0"/>
           </a:p>
@@ -8280,7 +8280,7 @@
                 <a:ea typeface="Cambria" pitchFamily="34" charset="-122"/>
                 <a:cs typeface="Cambria" pitchFamily="34" charset="-120"/>
               </a:rPr>
-              <a:t>Adopt a site or a gallery</a:t>
+              <a:t>Adopt a gallery in the museum</a:t>
             </a:r>
             <a:endParaRPr lang="en-US" sz="1450" dirty="0"/>
           </a:p>
@@ -8319,7 +8319,7 @@
                 <a:ea typeface="Calibri" pitchFamily="34" charset="-122"/>
                 <a:cs typeface="Calibri" pitchFamily="34" charset="-120"/>
               </a:rPr>
-              <a:t>Fund the scanning of one site, or one gallery in the virtual museum, and it carries your name in 3D and in the headset.</a:t>
+              <a:t>Fund one gallery of the virtual museum, walls to stories, and it carries your name in the browser and the headset.</a:t>
             </a:r>
             <a:endParaRPr lang="en-US" sz="1150" dirty="0"/>
           </a:p>
@@ -8434,7 +8434,7 @@
                 <a:ea typeface="Cambria" pitchFamily="34" charset="-122"/>
                 <a:cs typeface="Cambria" pitchFamily="34" charset="-120"/>
               </a:rPr>
-              <a:t>Bring a room to your event</a:t>
+              <a:t>Build an experience with us</a:t>
             </a:r>
             <a:endParaRPr lang="en-US" sz="1450" dirty="0"/>
           </a:p>
@@ -8473,7 +8473,7 @@
                 <a:ea typeface="Calibri" pitchFamily="34" charset="-122"/>
                 <a:cs typeface="Calibri" pitchFamily="34" charset="-120"/>
               </a:rPr>
-              <a:t>The 3D experience and a headset at your conference or office, with a volunteer to guide people through it.</a:t>
+              <a:t>Your developers, our volunteers and our published scans: an AR lesson, a VR room, a piece for your own event.</a:t>
             </a:r>
             <a:endParaRPr lang="en-US" sz="1150" dirty="0"/>
           </a:p>
@@ -8588,7 +8588,7 @@
                 <a:ea typeface="Cambria" pitchFamily="34" charset="-122"/>
                 <a:cs typeface="Cambria" pitchFamily="34" charset="-120"/>
               </a:rPr>
-              <a:t>A talk or a workshop</a:t>
+              <a:t>A care day for a coastal site</a:t>
             </a:r>
             <a:endParaRPr lang="en-US" sz="1450" dirty="0"/>
           </a:p>
@@ -8627,7 +8627,7 @@
                 <a:ea typeface="Calibri" pitchFamily="34" charset="-122"/>
                 <a:cs typeface="Calibri" pitchFamily="34" charset="-120"/>
               </a:rPr>
-              <a:t>Our founder and team speak on phone photogrammetry, community XR and heritage at risk: AWE, Voices of VR, Georgia Tech, El Jem.</a:t>
+              <a:t>With the site authorities: cleaning and care at a coastal site with local volunteers, who are paid for their day.</a:t>
             </a:r>
             <a:endParaRPr lang="en-US" sz="1150" dirty="0"/>
           </a:p>
@@ -8742,7 +8742,7 @@
                 <a:ea typeface="Cambria" pitchFamily="34" charset="-122"/>
                 <a:cs typeface="Cambria" pitchFamily="34" charset="-120"/>
               </a:rPr>
-              <a:t>Sponsor a hackathon track</a:t>
+              <a:t>Learn 3D capture with a phone</a:t>
             </a:r>
             <a:endParaRPr lang="en-US" sz="1450" dirty="0"/>
           </a:p>
@@ -8781,7 +8781,7 @@
                 <a:ea typeface="Calibri" pitchFamily="34" charset="-122"/>
                 <a:cs typeface="Calibri" pitchFamily="34" charset="-120"/>
               </a:rPr>
-              <a:t>Real scans as the material. You set the challenge, meet the students, see what they build in a weekend.</a:t>
+              <a:t>A workshop for your team, on objects and places we are free to scan, with the method our volunteers use.</a:t>
             </a:r>
             <a:endParaRPr lang="en-US" sz="1150" dirty="0"/>
           </a:p>
@@ -8896,7 +8896,7 @@
                 <a:ea typeface="Cambria" pitchFamily="34" charset="-122"/>
                 <a:cs typeface="Cambria" pitchFamily="34" charset="-120"/>
               </a:rPr>
-              <a:t>Fund a scanning season</a:t>
+              <a:t>A talk or a room at your event</a:t>
             </a:r>
             <a:endParaRPr lang="en-US" sz="1450" dirty="0"/>
           </a:p>
@@ -8935,7 +8935,7 @@
                 <a:ea typeface="Calibri" pitchFamily="34" charset="-122"/>
                 <a:cs typeface="Calibri" pitchFamily="34" charset="-120"/>
               </a:rPr>
-              <a:t>Bus fares, data, backups and a modest fee for local volunteers, with sites, counts and stories reported monthly.</a:t>
+              <a:t>Our team speaks on community XR and heritage at risk, or brings the 3D experience and a headset to you.</a:t>
             </a:r>
             <a:endParaRPr lang="en-US" sz="1150" dirty="0"/>
           </a:p>
@@ -9127,7 +9127,7 @@
                 <a:ea typeface="Calibri" pitchFamily="34" charset="-122"/>
                 <a:cs typeface="Calibri" pitchFamily="34" charset="-120"/>
               </a:rPr>
-              <a:t>Every object your support made possible is public, in 3D, with your name beside it.</a:t>
+              <a:t>Every gallery, experience and piece your support made possible is public, in 3D, with your name beside it.</a:t>
             </a:r>
             <a:endParaRPr lang="en-US" sz="1500" dirty="0"/>
           </a:p>
@@ -9148,7 +9148,7 @@
                 <a:ea typeface="Calibri" pitchFamily="34" charset="-122"/>
                 <a:cs typeface="Calibri" pitchFamily="34" charset="-120"/>
               </a:rPr>
-              <a:t>Numbers, monthly: visits, objects viewed, people trained, sites documented, from the same counter we use ourselves.</a:t>
+              <a:t>Numbers, monthly: visits, objects viewed, people trained, volunteer hours, from the same counter we use ourselves.</a:t>
             </a:r>
             <a:endParaRPr lang="en-US" sz="1500" dirty="0"/>
           </a:p>

</xml_diff>